<commit_message>
Add live dashboard link to README and slides
https://ai4i-machine-failure-prediction.streamlit.app/ is now in the README
(top line and deployment notes), on the summary slide and on the thank-you
slide (clickable). Script PDF thumbnails refreshed to match.

Co-Authored-By: Claude Opus 5.5 <noreply@anthropic.com>
</commit_message>
<xml_diff>
--- a/Group11_Machine_Failure_Prediction.pptx
+++ b/Group11_Machine_Failure_Prediction.pptx
@@ -113,29 +113,29 @@
   <p:extLst>
     <p:ext uri="{521415D9-36F7-43E2-AB2F-B90AF26B5E84}">
       <p14:sectionLst xmlns:p14="http://schemas.microsoft.com/office/powerpoint/2010/main">
-        <p14:section name="Introduction" id="{04b00388-cc96-7686-db87-18cdc7c248cf}">
+        <p14:section name="Introduction" id="{4120316e-c55f-a9bb-5b3a-ed3f46a42cbe}">
           <p14:sldIdLst>
             <p14:sldId id="256"/>
           </p14:sldIdLst>
         </p14:section>
-        <p14:section name="Problem and data" id="{0e9572da-e4b8-9f7a-9509-c93c7384c751}">
+        <p14:section name="Problem and data" id="{c24c7769-aaf9-8c5a-950e-8a18ac70a326}">
           <p14:sldIdLst>
             <p14:sldId id="257"/>
             <p14:sldId id="258"/>
           </p14:sldIdLst>
         </p14:section>
-        <p14:section name="Method" id="{7d8b0075-b957-e982-0a47-68d7b4d6bf7d}">
+        <p14:section name="Method" id="{0d88a964-ee75-e6d5-46b4-bc397567feeb}">
           <p14:sldIdLst>
             <p14:sldId id="259"/>
           </p14:sldIdLst>
         </p14:section>
-        <p14:section name="Results" id="{0aa2a0b8-9605-38d1-19da-9a1eabb9a4eb}">
+        <p14:section name="Results" id="{4258cedf-864a-416e-ba5d-d09bdf4090e3}">
           <p14:sldIdLst>
             <p14:sldId id="260"/>
             <p14:sldId id="261"/>
           </p14:sldIdLst>
         </p14:section>
-        <p14:section name="Close" id="{dc6645ad-1e86-4a3f-64dd-922d8115d3b3}">
+        <p14:section name="Close" id="{d55d952f-de69-dba2-6149-9dab478fe948}">
           <p14:sldIdLst>
             <p14:sldId id="262"/>
           </p14:sldIdLst>
@@ -10979,14 +10979,14 @@
       </p:sp>
       <p:sp>
         <p:nvSpPr>
-          <p:cNvPr id="21" name="Dashboard note"/>
+          <p:cNvPr id="21" name="Dashboard link"/>
           <p:cNvSpPr txBox="1"/>
           <p:nvPr/>
         </p:nvSpPr>
         <p:spPr>
           <a:xfrm>
-            <a:off x="7498080" y="5715000"/>
-            <a:ext cx="3931920" cy="365760"/>
+            <a:off x="7498080" y="5532120"/>
+            <a:ext cx="4023360" cy="548640"/>
           </a:xfrm>
           <a:prstGeom prst="rect">
             <a:avLst/>
@@ -10995,21 +10995,42 @@
           <a:ln/>
         </p:spPr>
         <p:txBody>
-          <a:bodyPr wrap="square" lIns="0" tIns="0" rIns="0" bIns="0" rtlCol="0" anchor="ctr"/>
+          <a:bodyPr wrap="square" lIns="0" tIns="0" rIns="0" bIns="0" rtlCol="0" anchor="t"/>
           <a:lstStyle/>
           <a:p>
             <a:pPr indent="0" marL="0">
               <a:buNone/>
             </a:pPr>
             <a:r>
-              <a:rPr lang="en-US" sz="1100" i="1" dirty="0">
+              <a:rPr lang="en-US" sz="1200" i="1" dirty="0">
                 <a:solidFill>
                   <a:schemeClr val="accent5"/>
                 </a:solidFill>
               </a:rPr>
-              <a:t>Try it live in the Streamlit dashboard</a:t>
-            </a:r>
-            <a:endParaRPr lang="en-US" sz="1100" dirty="0"/>
+              <a:t>Try it live:</a:t>
+            </a:r>
+            <a:endParaRPr lang="en-US" sz="1200" dirty="0"/>
+          </a:p>
+          <a:p>
+            <a:pPr indent="0" marL="0">
+              <a:buNone/>
+            </a:pPr>
+            <a:r>
+              <a:rPr lang="en-US" sz="1200" b="1" u="sng" dirty="0">
+                <a:solidFill>
+                  <a:schemeClr val="accent2"/>
+                </a:solidFill>
+                <a:hlinkClick r:id="rId5" invalidUrl="" action="" tgtFrame="" tooltip="Open the live dashboard" history="1" highlightClick="0" endSnd="0">
+                  <a:extLst>
+                    <a:ext uri="{A12FA001-AC4F-418D-AE19-62706E023703}">
+                      <ahyp:hlinkClr xmlns:ahyp="http://schemas.microsoft.com/office/drawing/2018/hyperlinkcolor" val="tx"/>
+                    </a:ext>
+                  </a:extLst>
+                </a:hlinkClick>
+              </a:rPr>
+              <a:t>ai4i-machine-failure-prediction.streamlit.app</a:t>
+            </a:r>
+            <a:endParaRPr lang="en-US" sz="1200" dirty="0"/>
           </a:p>
         </p:txBody>
       </p:sp>
@@ -11159,7 +11180,61 @@
       </p:sp>
       <p:sp>
         <p:nvSpPr>
-          <p:cNvPr id="4" name="Team line"/>
+          <p:cNvPr id="4" name="Dashboard link"/>
+          <p:cNvSpPr txBox="1"/>
+          <p:nvPr/>
+        </p:nvSpPr>
+        <p:spPr>
+          <a:xfrm>
+            <a:off x="685800" y="4069080"/>
+            <a:ext cx="8229600" cy="411480"/>
+          </a:xfrm>
+          <a:prstGeom prst="rect">
+            <a:avLst/>
+          </a:prstGeom>
+          <a:noFill/>
+          <a:ln/>
+        </p:spPr>
+        <p:txBody>
+          <a:bodyPr wrap="square" lIns="0" tIns="0" rIns="0" bIns="0" rtlCol="0" anchor="ctr"/>
+          <a:lstStyle/>
+          <a:p>
+            <a:pPr indent="0" marL="0">
+              <a:buNone/>
+            </a:pPr>
+            <a:r>
+              <a:rPr lang="en-US" sz="1600" dirty="0">
+                <a:solidFill>
+                  <a:schemeClr val="accent5"/>
+                </a:solidFill>
+              </a:rPr>
+              <a:t>Live dashboard   </a:t>
+            </a:r>
+            <a:pPr indent="0" marL="0">
+              <a:buNone/>
+            </a:pPr>
+            <a:r>
+              <a:rPr lang="en-US" sz="1600" b="1" u="sng" dirty="0">
+                <a:solidFill>
+                  <a:schemeClr val="bg1"/>
+                </a:solidFill>
+                <a:hlinkClick r:id="rId1" invalidUrl="" action="" tgtFrame="" tooltip="Open the live dashboard" history="1" highlightClick="0" endSnd="0">
+                  <a:extLst>
+                    <a:ext uri="{A12FA001-AC4F-418D-AE19-62706E023703}">
+                      <ahyp:hlinkClr xmlns:ahyp="http://schemas.microsoft.com/office/drawing/2018/hyperlinkcolor" val="tx"/>
+                    </a:ext>
+                  </a:extLst>
+                </a:hlinkClick>
+              </a:rPr>
+              <a:t>ai4i-machine-failure-prediction.streamlit.app</a:t>
+            </a:r>
+            <a:endParaRPr lang="en-US" sz="1600" dirty="0"/>
+          </a:p>
+        </p:txBody>
+      </p:sp>
+      <p:sp>
+        <p:nvSpPr>
+          <p:cNvPr id="5" name="Team line"/>
           <p:cNvSpPr txBox="1"/>
           <p:nvPr/>
         </p:nvSpPr>

</xml_diff>